<commit_message>
Sharpen the wording on the Japan long-end slide
</commit_message>
<xml_diff>
--- a/Japan_Long_End_Repricing.pptx
+++ b/Japan_Long_End_Repricing.pptx
@@ -9924,7 +9924,7 @@
                 </a:solidFill>
                 <a:latin typeface="Arial"/>
               </a:rPr>
-              <a:t>Exhibit 1. QT is lifting the long end while the front end stays anchored</a:t>
+              <a:t>Exhibit 1. Quantitative tightening is lifting the long end; the front end remains anchored</a:t>
             </a:r>
           </a:p>
         </p:txBody>
@@ -10614,7 +10614,7 @@
                 </a:solidFill>
                 <a:latin typeface="Arial"/>
               </a:rPr>
-              <a:t>Exhibit 2. A ¥1,013.8tn market must clear with less official support</a:t>
+              <a:t>Exhibit 2. A ¥1,013.8tn market must now clear without its largest buyer</a:t>
             </a:r>
           </a:p>
         </p:txBody>
@@ -10758,7 +10758,7 @@
                 </a:solidFill>
                 <a:latin typeface="Arial"/>
               </a:rPr>
-              <a:t>still on the BoJ's balance sheet</a:t>
+              <a:t>held by the BoJ, and now shrinking</a:t>
             </a:r>
           </a:p>
         </p:txBody>
@@ -10842,7 +10842,7 @@
                 </a:solidFill>
                 <a:latin typeface="Arial"/>
               </a:rPr>
-              <a:t>FY26 issuance to be absorbed privately</a:t>
+              <a:t>FY26 issuance for private investors</a:t>
             </a:r>
           </a:p>
         </p:txBody>
@@ -11125,8 +11125,8 @@
         </p:nvSpPr>
         <p:spPr>
           <a:xfrm>
-            <a:off x="475488" y="4974336"/>
-            <a:ext cx="11247120" cy="914400"/>
+            <a:off x="475488" y="4937760"/>
+            <a:ext cx="11247120" cy="1024128"/>
           </a:xfrm>
           <a:prstGeom prst="rect">
             <a:avLst/>
@@ -11167,8 +11167,8 @@
         </p:nvSpPr>
         <p:spPr>
           <a:xfrm>
-            <a:off x="822960" y="5084064"/>
-            <a:ext cx="10552176" cy="731520"/>
+            <a:off x="786384" y="5029200"/>
+            <a:ext cx="10625328" cy="877824"/>
           </a:xfrm>
           <a:prstGeom prst="rect">
             <a:avLst/>
@@ -11183,20 +11183,20 @@
           <a:p>
             <a:pPr algn="ctr">
               <a:lnSpc>
-                <a:spcPct val="122000"/>
+                <a:spcPct val="120000"/>
               </a:lnSpc>
               <a:spcAft>
                 <a:spcPts val="0"/>
               </a:spcAft>
             </a:pPr>
             <a:r>
-              <a:rPr sz="1050" b="0" i="0">
+              <a:rPr sz="950" b="0" i="0">
                 <a:solidFill>
                   <a:srgbClr val="000000"/>
                 </a:solidFill>
                 <a:latin typeface="Arial"/>
               </a:rPr>
-              <a:t>Three regime changes at once. The BoJ is withdrawing after a quarter-century of suppression, a record stock of debt now has to clear through price-sensitive buyers, and the deflation equilibrium that justified zero yields has broken. Each raises the term premium the long end demands — and none of them moves the front end, which the Bank still controls and is moving slowly. That is a bear steepener.</a:t>
+              <a:t>Three structural changes are occurring at once: the Bank of Japan is withdrawing after twenty-five years of suppression, a record debt stock must now clear through price-sensitive investors, and the deflationary equilibrium that justified zero yields has ended. Describing this as a fiscal story is a misnomer. The stock accumulated over decades and the fiscal stance has not materially shifted; what changed is who absorbs the issuance. Each factor raises the term premium demanded at the long end, and none of them affects the front end, which the Bank continues to control and is normalising slowly. That combination is a bear steepener.</a:t>
             </a:r>
           </a:p>
         </p:txBody>
@@ -11209,7 +11209,7 @@
         </p:nvSpPr>
         <p:spPr>
           <a:xfrm>
-            <a:off x="475488" y="6053328"/>
+            <a:off x="475488" y="6089904"/>
             <a:ext cx="6949440" cy="201168"/>
           </a:xfrm>
           <a:prstGeom prst="rect">
@@ -11251,7 +11251,7 @@
         </p:nvSpPr>
         <p:spPr>
           <a:xfrm>
-            <a:off x="475488" y="6053328"/>
+            <a:off x="475488" y="6089904"/>
             <a:ext cx="11247120" cy="201168"/>
           </a:xfrm>
           <a:prstGeom prst="rect">

</xml_diff>